<commit_message>
Done with RT sample fig
</commit_message>
<xml_diff>
--- a/figures/figures for patent application.pptx
+++ b/figures/figures for patent application.pptx
@@ -9,6 +9,7 @@
     <p:sldId id="257" r:id="rId3"/>
     <p:sldId id="258" r:id="rId4"/>
     <p:sldId id="259" r:id="rId5"/>
+    <p:sldId id="260" r:id="rId6"/>
   </p:sldIdLst>
   <p:sldSz cx="12192000" cy="6858000"/>
   <p:notesSz cx="6858000" cy="9144000"/>
@@ -107,6 +108,11 @@
       </a:defRPr>
     </a:lvl9pPr>
   </p:defaultTextStyle>
+  <p:extLst>
+    <p:ext uri="{EFAFB233-063F-42B5-8137-9DF3F51BA10A}">
+      <p15:sldGuideLst xmlns:p15="http://schemas.microsoft.com/office/powerpoint/2012/main"/>
+    </p:ext>
+  </p:extLst>
 </p:presentation>
 </file>
 
@@ -257,7 +263,7 @@
           <a:p>
             <a:fld id="{DB945976-3FE5-4A9F-9859-FC8472DD523D}" type="datetimeFigureOut">
               <a:rPr lang="en-US" smtClean="0"/>
-              <a:t>4/29/2025</a:t>
+              <a:t>5/1/2025</a:t>
             </a:fld>
             <a:endParaRPr lang="en-US"/>
           </a:p>
@@ -455,7 +461,7 @@
           <a:p>
             <a:fld id="{DB945976-3FE5-4A9F-9859-FC8472DD523D}" type="datetimeFigureOut">
               <a:rPr lang="en-US" smtClean="0"/>
-              <a:t>4/29/2025</a:t>
+              <a:t>5/1/2025</a:t>
             </a:fld>
             <a:endParaRPr lang="en-US"/>
           </a:p>
@@ -663,7 +669,7 @@
           <a:p>
             <a:fld id="{DB945976-3FE5-4A9F-9859-FC8472DD523D}" type="datetimeFigureOut">
               <a:rPr lang="en-US" smtClean="0"/>
-              <a:t>4/29/2025</a:t>
+              <a:t>5/1/2025</a:t>
             </a:fld>
             <a:endParaRPr lang="en-US"/>
           </a:p>
@@ -861,7 +867,7 @@
           <a:p>
             <a:fld id="{DB945976-3FE5-4A9F-9859-FC8472DD523D}" type="datetimeFigureOut">
               <a:rPr lang="en-US" smtClean="0"/>
-              <a:t>4/29/2025</a:t>
+              <a:t>5/1/2025</a:t>
             </a:fld>
             <a:endParaRPr lang="en-US"/>
           </a:p>
@@ -1136,7 +1142,7 @@
           <a:p>
             <a:fld id="{DB945976-3FE5-4A9F-9859-FC8472DD523D}" type="datetimeFigureOut">
               <a:rPr lang="en-US" smtClean="0"/>
-              <a:t>4/29/2025</a:t>
+              <a:t>5/1/2025</a:t>
             </a:fld>
             <a:endParaRPr lang="en-US"/>
           </a:p>
@@ -1401,7 +1407,7 @@
           <a:p>
             <a:fld id="{DB945976-3FE5-4A9F-9859-FC8472DD523D}" type="datetimeFigureOut">
               <a:rPr lang="en-US" smtClean="0"/>
-              <a:t>4/29/2025</a:t>
+              <a:t>5/1/2025</a:t>
             </a:fld>
             <a:endParaRPr lang="en-US"/>
           </a:p>
@@ -1813,7 +1819,7 @@
           <a:p>
             <a:fld id="{DB945976-3FE5-4A9F-9859-FC8472DD523D}" type="datetimeFigureOut">
               <a:rPr lang="en-US" smtClean="0"/>
-              <a:t>4/29/2025</a:t>
+              <a:t>5/1/2025</a:t>
             </a:fld>
             <a:endParaRPr lang="en-US"/>
           </a:p>
@@ -1954,7 +1960,7 @@
           <a:p>
             <a:fld id="{DB945976-3FE5-4A9F-9859-FC8472DD523D}" type="datetimeFigureOut">
               <a:rPr lang="en-US" smtClean="0"/>
-              <a:t>4/29/2025</a:t>
+              <a:t>5/1/2025</a:t>
             </a:fld>
             <a:endParaRPr lang="en-US"/>
           </a:p>
@@ -2067,7 +2073,7 @@
           <a:p>
             <a:fld id="{DB945976-3FE5-4A9F-9859-FC8472DD523D}" type="datetimeFigureOut">
               <a:rPr lang="en-US" smtClean="0"/>
-              <a:t>4/29/2025</a:t>
+              <a:t>5/1/2025</a:t>
             </a:fld>
             <a:endParaRPr lang="en-US"/>
           </a:p>
@@ -2378,7 +2384,7 @@
           <a:p>
             <a:fld id="{DB945976-3FE5-4A9F-9859-FC8472DD523D}" type="datetimeFigureOut">
               <a:rPr lang="en-US" smtClean="0"/>
-              <a:t>4/29/2025</a:t>
+              <a:t>5/1/2025</a:t>
             </a:fld>
             <a:endParaRPr lang="en-US"/>
           </a:p>
@@ -2666,7 +2672,7 @@
           <a:p>
             <a:fld id="{DB945976-3FE5-4A9F-9859-FC8472DD523D}" type="datetimeFigureOut">
               <a:rPr lang="en-US" smtClean="0"/>
-              <a:t>4/29/2025</a:t>
+              <a:t>5/1/2025</a:t>
             </a:fld>
             <a:endParaRPr lang="en-US"/>
           </a:p>
@@ -2907,7 +2913,7 @@
           <a:p>
             <a:fld id="{DB945976-3FE5-4A9F-9859-FC8472DD523D}" type="datetimeFigureOut">
               <a:rPr lang="en-US" smtClean="0"/>
-              <a:t>4/29/2025</a:t>
+              <a:t>5/1/2025</a:t>
             </a:fld>
             <a:endParaRPr lang="en-US"/>
           </a:p>
@@ -7005,6 +7011,144 @@
 </p:sld>
 </file>
 
+<file path=ppt/slides/slide5.xml><?xml version="1.0" encoding="utf-8"?>
+<p:sld xmlns:a="http://schemas.openxmlformats.org/drawingml/2006/main" xmlns:r="http://schemas.openxmlformats.org/officeDocument/2006/relationships" xmlns:p="http://schemas.openxmlformats.org/presentationml/2006/main">
+  <p:cSld>
+    <p:spTree>
+      <p:nvGrpSpPr>
+        <p:cNvPr id="1" name=""/>
+        <p:cNvGrpSpPr/>
+        <p:nvPr/>
+      </p:nvGrpSpPr>
+      <p:grpSpPr>
+        <a:xfrm>
+          <a:off x="0" y="0"/>
+          <a:ext cx="0" cy="0"/>
+          <a:chOff x="0" y="0"/>
+          <a:chExt cx="0" cy="0"/>
+        </a:xfrm>
+      </p:grpSpPr>
+      <p:pic>
+        <p:nvPicPr>
+          <p:cNvPr id="5" name="Picture 4" descr="A graph showing a number of dots&#10;&#10;AI-generated content may be incorrect.">
+            <a:extLst>
+              <a:ext uri="{FF2B5EF4-FFF2-40B4-BE49-F238E27FC236}">
+                <a16:creationId xmlns:a16="http://schemas.microsoft.com/office/drawing/2014/main" id="{0FF1AC1F-8E09-A4A1-1B06-86C786A2AA02}"/>
+              </a:ext>
+            </a:extLst>
+          </p:cNvPr>
+          <p:cNvPicPr>
+            <a:picLocks noChangeAspect="1"/>
+          </p:cNvPicPr>
+          <p:nvPr/>
+        </p:nvPicPr>
+        <p:blipFill>
+          <a:blip r:embed="rId2">
+            <a:extLst>
+              <a:ext uri="{28A0092B-C50C-407E-A947-70E740481C1C}">
+                <a14:useLocalDpi xmlns:a14="http://schemas.microsoft.com/office/drawing/2010/main" val="0"/>
+              </a:ext>
+            </a:extLst>
+          </a:blip>
+          <a:stretch>
+            <a:fillRect/>
+          </a:stretch>
+        </p:blipFill>
+        <p:spPr>
+          <a:xfrm>
+            <a:off x="1103138" y="1388243"/>
+            <a:ext cx="3017526" cy="3950216"/>
+          </a:xfrm>
+          <a:prstGeom prst="rect">
+            <a:avLst/>
+          </a:prstGeom>
+        </p:spPr>
+      </p:pic>
+      <p:sp>
+        <p:nvSpPr>
+          <p:cNvPr id="6" name="TextBox 5">
+            <a:extLst>
+              <a:ext uri="{FF2B5EF4-FFF2-40B4-BE49-F238E27FC236}">
+                <a16:creationId xmlns:a16="http://schemas.microsoft.com/office/drawing/2014/main" id="{A4057A34-A99D-48F4-A087-77D40043C767}"/>
+              </a:ext>
+            </a:extLst>
+          </p:cNvPr>
+          <p:cNvSpPr txBox="1"/>
+          <p:nvPr/>
+        </p:nvSpPr>
+        <p:spPr>
+          <a:xfrm>
+            <a:off x="2914520" y="3767827"/>
+            <a:ext cx="924127" cy="230832"/>
+          </a:xfrm>
+          <a:prstGeom prst="rect">
+            <a:avLst/>
+          </a:prstGeom>
+          <a:solidFill>
+            <a:schemeClr val="bg1"/>
+          </a:solidFill>
+        </p:spPr>
+        <p:txBody>
+          <a:bodyPr wrap="square" rtlCol="0">
+            <a:spAutoFit/>
+          </a:bodyPr>
+          <a:lstStyle/>
+          <a:p>
+            <a:r>
+              <a:rPr lang="en-US" sz="900" b="1" dirty="0"/>
+              <a:t>539 features</a:t>
+            </a:r>
+          </a:p>
+        </p:txBody>
+      </p:sp>
+      <p:sp>
+        <p:nvSpPr>
+          <p:cNvPr id="7" name="TextBox 6">
+            <a:extLst>
+              <a:ext uri="{FF2B5EF4-FFF2-40B4-BE49-F238E27FC236}">
+                <a16:creationId xmlns:a16="http://schemas.microsoft.com/office/drawing/2014/main" id="{23A250BE-0B65-BE91-4449-C546ED0FCCDD}"/>
+              </a:ext>
+            </a:extLst>
+          </p:cNvPr>
+          <p:cNvSpPr txBox="1"/>
+          <p:nvPr/>
+        </p:nvSpPr>
+        <p:spPr>
+          <a:xfrm>
+            <a:off x="3012993" y="2428028"/>
+            <a:ext cx="886407" cy="230832"/>
+          </a:xfrm>
+          <a:prstGeom prst="rect">
+            <a:avLst/>
+          </a:prstGeom>
+          <a:noFill/>
+        </p:spPr>
+        <p:txBody>
+          <a:bodyPr wrap="square" rtlCol="0">
+            <a:spAutoFit/>
+          </a:bodyPr>
+          <a:lstStyle/>
+          <a:p>
+            <a:r>
+              <a:rPr lang="en-US" sz="900" b="1" dirty="0"/>
+              <a:t>224 features</a:t>
+            </a:r>
+          </a:p>
+        </p:txBody>
+      </p:sp>
+    </p:spTree>
+    <p:extLst>
+      <p:ext uri="{BB962C8B-B14F-4D97-AF65-F5344CB8AC3E}">
+        <p14:creationId xmlns:p14="http://schemas.microsoft.com/office/powerpoint/2010/main" val="674222147"/>
+      </p:ext>
+    </p:extLst>
+  </p:cSld>
+  <p:clrMapOvr>
+    <a:masterClrMapping/>
+  </p:clrMapOvr>
+</p:sld>
+</file>
+
 <file path=ppt/theme/theme1.xml><?xml version="1.0" encoding="utf-8"?>
 <a:theme xmlns:a="http://schemas.openxmlformats.org/drawingml/2006/main" name="Office Theme">
   <a:themeElements>

</xml_diff>

<commit_message>
Finished with the linear regression analysis figure
</commit_message>
<xml_diff>
--- a/figures/figures for patent application.pptx
+++ b/figures/figures for patent application.pptx
@@ -10,6 +10,7 @@
     <p:sldId id="258" r:id="rId4"/>
     <p:sldId id="259" r:id="rId5"/>
     <p:sldId id="260" r:id="rId6"/>
+    <p:sldId id="261" r:id="rId7"/>
   </p:sldIdLst>
   <p:sldSz cx="12192000" cy="6858000"/>
   <p:notesSz cx="6858000" cy="9144000"/>
@@ -7028,12 +7029,528 @@
           <a:chExt cx="0" cy="0"/>
         </a:xfrm>
       </p:grpSpPr>
+      <p:grpSp>
+        <p:nvGrpSpPr>
+          <p:cNvPr id="30" name="Group 29">
+            <a:extLst>
+              <a:ext uri="{FF2B5EF4-FFF2-40B4-BE49-F238E27FC236}">
+                <a16:creationId xmlns:a16="http://schemas.microsoft.com/office/drawing/2014/main" id="{001EA3A0-6DAC-DFB1-F661-77EA76B540C4}"/>
+              </a:ext>
+            </a:extLst>
+          </p:cNvPr>
+          <p:cNvGrpSpPr/>
+          <p:nvPr/>
+        </p:nvGrpSpPr>
+        <p:grpSpPr>
+          <a:xfrm>
+            <a:off x="3295878" y="1658609"/>
+            <a:ext cx="3017526" cy="3950216"/>
+            <a:chOff x="3295878" y="1453892"/>
+            <a:chExt cx="3017526" cy="3950216"/>
+          </a:xfrm>
+        </p:grpSpPr>
+        <p:pic>
+          <p:nvPicPr>
+            <p:cNvPr id="5" name="Picture 4" descr="A graph showing a number of dots&#10;&#10;AI-generated content may be incorrect.">
+              <a:extLst>
+                <a:ext uri="{FF2B5EF4-FFF2-40B4-BE49-F238E27FC236}">
+                  <a16:creationId xmlns:a16="http://schemas.microsoft.com/office/drawing/2014/main" id="{0FF1AC1F-8E09-A4A1-1B06-86C786A2AA02}"/>
+                </a:ext>
+              </a:extLst>
+            </p:cNvPr>
+            <p:cNvPicPr>
+              <a:picLocks noChangeAspect="1"/>
+            </p:cNvPicPr>
+            <p:nvPr/>
+          </p:nvPicPr>
+          <p:blipFill>
+            <a:blip r:embed="rId2">
+              <a:extLst>
+                <a:ext uri="{28A0092B-C50C-407E-A947-70E740481C1C}">
+                  <a14:useLocalDpi xmlns:a14="http://schemas.microsoft.com/office/drawing/2010/main" val="0"/>
+                </a:ext>
+              </a:extLst>
+            </a:blip>
+            <a:stretch>
+              <a:fillRect/>
+            </a:stretch>
+          </p:blipFill>
+          <p:spPr>
+            <a:xfrm>
+              <a:off x="3295878" y="1453892"/>
+              <a:ext cx="3017526" cy="3950216"/>
+            </a:xfrm>
+            <a:prstGeom prst="rect">
+              <a:avLst/>
+            </a:prstGeom>
+          </p:spPr>
+        </p:pic>
+        <p:sp>
+          <p:nvSpPr>
+            <p:cNvPr id="6" name="TextBox 5">
+              <a:extLst>
+                <a:ext uri="{FF2B5EF4-FFF2-40B4-BE49-F238E27FC236}">
+                  <a16:creationId xmlns:a16="http://schemas.microsoft.com/office/drawing/2014/main" id="{A4057A34-A99D-48F4-A087-77D40043C767}"/>
+                </a:ext>
+              </a:extLst>
+            </p:cNvPr>
+            <p:cNvSpPr txBox="1"/>
+            <p:nvPr/>
+          </p:nvSpPr>
+          <p:spPr>
+            <a:xfrm>
+              <a:off x="5107260" y="3833476"/>
+              <a:ext cx="924127" cy="230832"/>
+            </a:xfrm>
+            <a:prstGeom prst="rect">
+              <a:avLst/>
+            </a:prstGeom>
+            <a:solidFill>
+              <a:schemeClr val="bg1"/>
+            </a:solidFill>
+          </p:spPr>
+          <p:txBody>
+            <a:bodyPr wrap="square" rtlCol="0">
+              <a:spAutoFit/>
+            </a:bodyPr>
+            <a:lstStyle/>
+            <a:p>
+              <a:r>
+                <a:rPr lang="en-US" sz="900" b="1" dirty="0"/>
+                <a:t>539 features</a:t>
+              </a:r>
+            </a:p>
+          </p:txBody>
+        </p:sp>
+        <p:sp>
+          <p:nvSpPr>
+            <p:cNvPr id="7" name="TextBox 6">
+              <a:extLst>
+                <a:ext uri="{FF2B5EF4-FFF2-40B4-BE49-F238E27FC236}">
+                  <a16:creationId xmlns:a16="http://schemas.microsoft.com/office/drawing/2014/main" id="{23A250BE-0B65-BE91-4449-C546ED0FCCDD}"/>
+                </a:ext>
+              </a:extLst>
+            </p:cNvPr>
+            <p:cNvSpPr txBox="1"/>
+            <p:nvPr/>
+          </p:nvSpPr>
+          <p:spPr>
+            <a:xfrm>
+              <a:off x="5205733" y="2493677"/>
+              <a:ext cx="886407" cy="230832"/>
+            </a:xfrm>
+            <a:prstGeom prst="rect">
+              <a:avLst/>
+            </a:prstGeom>
+            <a:noFill/>
+          </p:spPr>
+          <p:txBody>
+            <a:bodyPr wrap="square" rtlCol="0">
+              <a:spAutoFit/>
+            </a:bodyPr>
+            <a:lstStyle/>
+            <a:p>
+              <a:r>
+                <a:rPr lang="en-US" sz="900" b="1" dirty="0"/>
+                <a:t>224 features</a:t>
+              </a:r>
+            </a:p>
+          </p:txBody>
+        </p:sp>
+      </p:grpSp>
+      <p:grpSp>
+        <p:nvGrpSpPr>
+          <p:cNvPr id="29" name="Group 28">
+            <a:extLst>
+              <a:ext uri="{FF2B5EF4-FFF2-40B4-BE49-F238E27FC236}">
+                <a16:creationId xmlns:a16="http://schemas.microsoft.com/office/drawing/2014/main" id="{C651AAF6-31EF-6F9C-1FAB-8926C6D18BAC}"/>
+              </a:ext>
+            </a:extLst>
+          </p:cNvPr>
+          <p:cNvGrpSpPr/>
+          <p:nvPr/>
+        </p:nvGrpSpPr>
+        <p:grpSpPr>
+          <a:xfrm>
+            <a:off x="278352" y="1658609"/>
+            <a:ext cx="3017526" cy="3950216"/>
+            <a:chOff x="278352" y="1453892"/>
+            <a:chExt cx="3017526" cy="3950216"/>
+          </a:xfrm>
+        </p:grpSpPr>
+        <p:pic>
+          <p:nvPicPr>
+            <p:cNvPr id="8" name="Picture 7" descr="A graph of a line with dots&#10;&#10;AI-generated content may be incorrect.">
+              <a:extLst>
+                <a:ext uri="{FF2B5EF4-FFF2-40B4-BE49-F238E27FC236}">
+                  <a16:creationId xmlns:a16="http://schemas.microsoft.com/office/drawing/2014/main" id="{A1C3FF27-8326-8C82-91A7-DCC96C3B6FE2}"/>
+                </a:ext>
+              </a:extLst>
+            </p:cNvPr>
+            <p:cNvPicPr>
+              <a:picLocks noChangeAspect="1"/>
+            </p:cNvPicPr>
+            <p:nvPr/>
+          </p:nvPicPr>
+          <p:blipFill>
+            <a:blip r:embed="rId3">
+              <a:extLst>
+                <a:ext uri="{28A0092B-C50C-407E-A947-70E740481C1C}">
+                  <a14:useLocalDpi xmlns:a14="http://schemas.microsoft.com/office/drawing/2010/main" val="0"/>
+                </a:ext>
+              </a:extLst>
+            </a:blip>
+            <a:stretch>
+              <a:fillRect/>
+            </a:stretch>
+          </p:blipFill>
+          <p:spPr>
+            <a:xfrm>
+              <a:off x="278352" y="1453892"/>
+              <a:ext cx="3017526" cy="3950216"/>
+            </a:xfrm>
+            <a:prstGeom prst="rect">
+              <a:avLst/>
+            </a:prstGeom>
+          </p:spPr>
+        </p:pic>
+        <p:sp>
+          <p:nvSpPr>
+            <p:cNvPr id="9" name="TextBox 8">
+              <a:extLst>
+                <a:ext uri="{FF2B5EF4-FFF2-40B4-BE49-F238E27FC236}">
+                  <a16:creationId xmlns:a16="http://schemas.microsoft.com/office/drawing/2014/main" id="{5BA9CEBE-242E-C60C-039A-20798F2E2266}"/>
+                </a:ext>
+              </a:extLst>
+            </p:cNvPr>
+            <p:cNvSpPr txBox="1"/>
+            <p:nvPr/>
+          </p:nvSpPr>
+          <p:spPr>
+            <a:xfrm>
+              <a:off x="2236681" y="3833476"/>
+              <a:ext cx="924127" cy="230832"/>
+            </a:xfrm>
+            <a:prstGeom prst="rect">
+              <a:avLst/>
+            </a:prstGeom>
+            <a:solidFill>
+              <a:schemeClr val="bg1"/>
+            </a:solidFill>
+          </p:spPr>
+          <p:txBody>
+            <a:bodyPr wrap="square" rtlCol="0">
+              <a:spAutoFit/>
+            </a:bodyPr>
+            <a:lstStyle/>
+            <a:p>
+              <a:r>
+                <a:rPr lang="en-US" sz="900" b="1" dirty="0"/>
+                <a:t>22 features</a:t>
+              </a:r>
+            </a:p>
+          </p:txBody>
+        </p:sp>
+        <p:sp>
+          <p:nvSpPr>
+            <p:cNvPr id="10" name="TextBox 9">
+              <a:extLst>
+                <a:ext uri="{FF2B5EF4-FFF2-40B4-BE49-F238E27FC236}">
+                  <a16:creationId xmlns:a16="http://schemas.microsoft.com/office/drawing/2014/main" id="{064FBED3-2A27-86E9-8300-C36B9CF1641F}"/>
+                </a:ext>
+              </a:extLst>
+            </p:cNvPr>
+            <p:cNvSpPr txBox="1"/>
+            <p:nvPr/>
+          </p:nvSpPr>
+          <p:spPr>
+            <a:xfrm>
+              <a:off x="2335154" y="2493677"/>
+              <a:ext cx="886407" cy="230832"/>
+            </a:xfrm>
+            <a:prstGeom prst="rect">
+              <a:avLst/>
+            </a:prstGeom>
+            <a:noFill/>
+          </p:spPr>
+          <p:txBody>
+            <a:bodyPr wrap="square" rtlCol="0">
+              <a:spAutoFit/>
+            </a:bodyPr>
+            <a:lstStyle/>
+            <a:p>
+              <a:r>
+                <a:rPr lang="en-US" sz="900" b="1" dirty="0"/>
+                <a:t>78 features</a:t>
+              </a:r>
+            </a:p>
+          </p:txBody>
+        </p:sp>
+      </p:grpSp>
+      <p:grpSp>
+        <p:nvGrpSpPr>
+          <p:cNvPr id="31" name="Group 30">
+            <a:extLst>
+              <a:ext uri="{FF2B5EF4-FFF2-40B4-BE49-F238E27FC236}">
+                <a16:creationId xmlns:a16="http://schemas.microsoft.com/office/drawing/2014/main" id="{44D9C5C1-44A6-830E-648B-191FA38E3539}"/>
+              </a:ext>
+            </a:extLst>
+          </p:cNvPr>
+          <p:cNvGrpSpPr/>
+          <p:nvPr/>
+        </p:nvGrpSpPr>
+        <p:grpSpPr>
+          <a:xfrm>
+            <a:off x="6160615" y="1658609"/>
+            <a:ext cx="3017526" cy="3950216"/>
+            <a:chOff x="6160615" y="1549426"/>
+            <a:chExt cx="3017526" cy="3950216"/>
+          </a:xfrm>
+        </p:grpSpPr>
+        <p:pic>
+          <p:nvPicPr>
+            <p:cNvPr id="14" name="Picture 13" descr="A graph of a curve&#10;&#10;AI-generated content may be incorrect.">
+              <a:extLst>
+                <a:ext uri="{FF2B5EF4-FFF2-40B4-BE49-F238E27FC236}">
+                  <a16:creationId xmlns:a16="http://schemas.microsoft.com/office/drawing/2014/main" id="{FF9B38C0-FC0E-9F1F-6312-E5F18F149A7D}"/>
+                </a:ext>
+              </a:extLst>
+            </p:cNvPr>
+            <p:cNvPicPr>
+              <a:picLocks noChangeAspect="1"/>
+            </p:cNvPicPr>
+            <p:nvPr/>
+          </p:nvPicPr>
+          <p:blipFill>
+            <a:blip r:embed="rId4">
+              <a:extLst>
+                <a:ext uri="{28A0092B-C50C-407E-A947-70E740481C1C}">
+                  <a14:useLocalDpi xmlns:a14="http://schemas.microsoft.com/office/drawing/2010/main" val="0"/>
+                </a:ext>
+              </a:extLst>
+            </a:blip>
+            <a:stretch>
+              <a:fillRect/>
+            </a:stretch>
+          </p:blipFill>
+          <p:spPr>
+            <a:xfrm>
+              <a:off x="6160615" y="1549426"/>
+              <a:ext cx="3017526" cy="3950216"/>
+            </a:xfrm>
+            <a:prstGeom prst="rect">
+              <a:avLst/>
+            </a:prstGeom>
+          </p:spPr>
+        </p:pic>
+        <p:sp>
+          <p:nvSpPr>
+            <p:cNvPr id="16" name="TextBox 15">
+              <a:extLst>
+                <a:ext uri="{FF2B5EF4-FFF2-40B4-BE49-F238E27FC236}">
+                  <a16:creationId xmlns:a16="http://schemas.microsoft.com/office/drawing/2014/main" id="{FC2704A7-7455-36CA-2E16-572888FC406E}"/>
+                </a:ext>
+              </a:extLst>
+            </p:cNvPr>
+            <p:cNvSpPr txBox="1"/>
+            <p:nvPr/>
+          </p:nvSpPr>
+          <p:spPr>
+            <a:xfrm>
+              <a:off x="8218913" y="3901715"/>
+              <a:ext cx="924127" cy="230832"/>
+            </a:xfrm>
+            <a:prstGeom prst="rect">
+              <a:avLst/>
+            </a:prstGeom>
+            <a:solidFill>
+              <a:schemeClr val="bg1"/>
+            </a:solidFill>
+          </p:spPr>
+          <p:txBody>
+            <a:bodyPr wrap="square" rtlCol="0">
+              <a:spAutoFit/>
+            </a:bodyPr>
+            <a:lstStyle/>
+            <a:p>
+              <a:r>
+                <a:rPr lang="en-US" sz="900" b="1" dirty="0"/>
+                <a:t>12 features</a:t>
+              </a:r>
+            </a:p>
+          </p:txBody>
+        </p:sp>
+        <p:sp>
+          <p:nvSpPr>
+            <p:cNvPr id="17" name="TextBox 16">
+              <a:extLst>
+                <a:ext uri="{FF2B5EF4-FFF2-40B4-BE49-F238E27FC236}">
+                  <a16:creationId xmlns:a16="http://schemas.microsoft.com/office/drawing/2014/main" id="{E134CE0D-CF04-1D76-7468-831C44631760}"/>
+                </a:ext>
+              </a:extLst>
+            </p:cNvPr>
+            <p:cNvSpPr txBox="1"/>
+            <p:nvPr/>
+          </p:nvSpPr>
+          <p:spPr>
+            <a:xfrm>
+              <a:off x="8252276" y="2861931"/>
+              <a:ext cx="886407" cy="230832"/>
+            </a:xfrm>
+            <a:prstGeom prst="rect">
+              <a:avLst/>
+            </a:prstGeom>
+            <a:noFill/>
+          </p:spPr>
+          <p:txBody>
+            <a:bodyPr wrap="square" rtlCol="0">
+              <a:spAutoFit/>
+            </a:bodyPr>
+            <a:lstStyle/>
+            <a:p>
+              <a:r>
+                <a:rPr lang="en-US" sz="900" b="1" dirty="0"/>
+                <a:t>88 features</a:t>
+              </a:r>
+            </a:p>
+          </p:txBody>
+        </p:sp>
+      </p:grpSp>
+      <p:grpSp>
+        <p:nvGrpSpPr>
+          <p:cNvPr id="32" name="Group 31">
+            <a:extLst>
+              <a:ext uri="{FF2B5EF4-FFF2-40B4-BE49-F238E27FC236}">
+                <a16:creationId xmlns:a16="http://schemas.microsoft.com/office/drawing/2014/main" id="{808D1055-64DA-ACF6-06C6-0A10EB03241D}"/>
+              </a:ext>
+            </a:extLst>
+          </p:cNvPr>
+          <p:cNvGrpSpPr/>
+          <p:nvPr/>
+        </p:nvGrpSpPr>
+        <p:grpSpPr>
+          <a:xfrm>
+            <a:off x="8990251" y="1658609"/>
+            <a:ext cx="3141649" cy="3950216"/>
+            <a:chOff x="8990251" y="1658609"/>
+            <a:chExt cx="3141649" cy="3950216"/>
+          </a:xfrm>
+        </p:grpSpPr>
+        <p:pic>
+          <p:nvPicPr>
+            <p:cNvPr id="20" name="Picture 19" descr="A graph of a graph showing a curve&#10;&#10;AI-generated content may be incorrect.">
+              <a:extLst>
+                <a:ext uri="{FF2B5EF4-FFF2-40B4-BE49-F238E27FC236}">
+                  <a16:creationId xmlns:a16="http://schemas.microsoft.com/office/drawing/2014/main" id="{AE854FB4-476A-EFE2-694B-04794E45B8FD}"/>
+                </a:ext>
+              </a:extLst>
+            </p:cNvPr>
+            <p:cNvPicPr>
+              <a:picLocks noChangeAspect="1"/>
+            </p:cNvPicPr>
+            <p:nvPr/>
+          </p:nvPicPr>
+          <p:blipFill>
+            <a:blip r:embed="rId5">
+              <a:extLst>
+                <a:ext uri="{28A0092B-C50C-407E-A947-70E740481C1C}">
+                  <a14:useLocalDpi xmlns:a14="http://schemas.microsoft.com/office/drawing/2010/main" val="0"/>
+                </a:ext>
+              </a:extLst>
+            </a:blip>
+            <a:stretch>
+              <a:fillRect/>
+            </a:stretch>
+          </p:blipFill>
+          <p:spPr>
+            <a:xfrm>
+              <a:off x="8990251" y="1658609"/>
+              <a:ext cx="3017526" cy="3950216"/>
+            </a:xfrm>
+            <a:prstGeom prst="rect">
+              <a:avLst/>
+            </a:prstGeom>
+          </p:spPr>
+        </p:pic>
+        <p:sp>
+          <p:nvSpPr>
+            <p:cNvPr id="21" name="TextBox 20">
+              <a:extLst>
+                <a:ext uri="{FF2B5EF4-FFF2-40B4-BE49-F238E27FC236}">
+                  <a16:creationId xmlns:a16="http://schemas.microsoft.com/office/drawing/2014/main" id="{71046B19-BE24-080F-E7F1-EF899661774F}"/>
+                </a:ext>
+              </a:extLst>
+            </p:cNvPr>
+            <p:cNvSpPr txBox="1"/>
+            <p:nvPr/>
+          </p:nvSpPr>
+          <p:spPr>
+            <a:xfrm>
+              <a:off x="11207773" y="3901715"/>
+              <a:ext cx="924127" cy="230832"/>
+            </a:xfrm>
+            <a:prstGeom prst="rect">
+              <a:avLst/>
+            </a:prstGeom>
+            <a:solidFill>
+              <a:schemeClr val="bg1"/>
+            </a:solidFill>
+          </p:spPr>
+          <p:txBody>
+            <a:bodyPr wrap="square" rtlCol="0">
+              <a:spAutoFit/>
+            </a:bodyPr>
+            <a:lstStyle/>
+            <a:p>
+              <a:r>
+                <a:rPr lang="en-US" sz="900" b="1" dirty="0"/>
+                <a:t>323 features</a:t>
+              </a:r>
+            </a:p>
+          </p:txBody>
+        </p:sp>
+        <p:sp>
+          <p:nvSpPr>
+            <p:cNvPr id="22" name="TextBox 21">
+              <a:extLst>
+                <a:ext uri="{FF2B5EF4-FFF2-40B4-BE49-F238E27FC236}">
+                  <a16:creationId xmlns:a16="http://schemas.microsoft.com/office/drawing/2014/main" id="{56BEF216-0AAB-0358-A27A-0F49C368F540}"/>
+                </a:ext>
+              </a:extLst>
+            </p:cNvPr>
+            <p:cNvSpPr txBox="1"/>
+            <p:nvPr/>
+          </p:nvSpPr>
+          <p:spPr>
+            <a:xfrm>
+              <a:off x="11241136" y="2861931"/>
+              <a:ext cx="886407" cy="230832"/>
+            </a:xfrm>
+            <a:prstGeom prst="rect">
+              <a:avLst/>
+            </a:prstGeom>
+            <a:noFill/>
+          </p:spPr>
+          <p:txBody>
+            <a:bodyPr wrap="square" rtlCol="0">
+              <a:spAutoFit/>
+            </a:bodyPr>
+            <a:lstStyle/>
+            <a:p>
+              <a:r>
+                <a:rPr lang="en-US" sz="900" b="1" dirty="0"/>
+                <a:t>440 features</a:t>
+              </a:r>
+            </a:p>
+          </p:txBody>
+        </p:sp>
+      </p:grpSp>
       <p:pic>
         <p:nvPicPr>
-          <p:cNvPr id="5" name="Picture 4" descr="A graph showing a number of dots&#10;&#10;AI-generated content may be incorrect.">
-            <a:extLst>
-              <a:ext uri="{FF2B5EF4-FFF2-40B4-BE49-F238E27FC236}">
-                <a16:creationId xmlns:a16="http://schemas.microsoft.com/office/drawing/2014/main" id="{0FF1AC1F-8E09-A4A1-1B06-86C786A2AA02}"/>
+          <p:cNvPr id="24" name="Picture 23">
+            <a:extLst>
+              <a:ext uri="{FF2B5EF4-FFF2-40B4-BE49-F238E27FC236}">
+                <a16:creationId xmlns:a16="http://schemas.microsoft.com/office/drawing/2014/main" id="{F0E0FF69-00B6-ECAC-7F0D-592A309A7BDF}"/>
               </a:ext>
             </a:extLst>
           </p:cNvPr>
@@ -7043,10 +7560,191 @@
           <p:nvPr/>
         </p:nvPicPr>
         <p:blipFill>
-          <a:blip r:embed="rId2">
-            <a:extLst>
-              <a:ext uri="{28A0092B-C50C-407E-A947-70E740481C1C}">
-                <a14:useLocalDpi xmlns:a14="http://schemas.microsoft.com/office/drawing/2010/main" val="0"/>
+          <a:blip r:embed="rId6"/>
+          <a:stretch>
+            <a:fillRect/>
+          </a:stretch>
+        </p:blipFill>
+        <p:spPr>
+          <a:xfrm>
+            <a:off x="928823" y="1818968"/>
+            <a:ext cx="457200" cy="457200"/>
+          </a:xfrm>
+          <a:prstGeom prst="rect">
+            <a:avLst/>
+          </a:prstGeom>
+        </p:spPr>
+      </p:pic>
+      <p:grpSp>
+        <p:nvGrpSpPr>
+          <p:cNvPr id="38" name="Group 37">
+            <a:extLst>
+              <a:ext uri="{FF2B5EF4-FFF2-40B4-BE49-F238E27FC236}">
+                <a16:creationId xmlns:a16="http://schemas.microsoft.com/office/drawing/2014/main" id="{AC2B1C9F-9420-AB0C-F8C1-2A13F28F59AF}"/>
+              </a:ext>
+            </a:extLst>
+          </p:cNvPr>
+          <p:cNvGrpSpPr/>
+          <p:nvPr/>
+        </p:nvGrpSpPr>
+        <p:grpSpPr>
+          <a:xfrm>
+            <a:off x="3864092" y="1795082"/>
+            <a:ext cx="596711" cy="568657"/>
+            <a:chOff x="3864092" y="1763239"/>
+            <a:chExt cx="596711" cy="568657"/>
+          </a:xfrm>
+        </p:grpSpPr>
+        <p:sp>
+          <p:nvSpPr>
+            <p:cNvPr id="37" name="Rectangle 36">
+              <a:extLst>
+                <a:ext uri="{FF2B5EF4-FFF2-40B4-BE49-F238E27FC236}">
+                  <a16:creationId xmlns:a16="http://schemas.microsoft.com/office/drawing/2014/main" id="{926F5415-04F0-675E-007B-E2F2FEC83846}"/>
+                </a:ext>
+              </a:extLst>
+            </p:cNvPr>
+            <p:cNvSpPr/>
+            <p:nvPr/>
+          </p:nvSpPr>
+          <p:spPr>
+            <a:xfrm>
+              <a:off x="3864092" y="1763239"/>
+              <a:ext cx="596711" cy="568657"/>
+            </a:xfrm>
+            <a:prstGeom prst="rect">
+              <a:avLst/>
+            </a:prstGeom>
+            <a:solidFill>
+              <a:schemeClr val="bg1"/>
+            </a:solidFill>
+            <a:ln>
+              <a:noFill/>
+            </a:ln>
+          </p:spPr>
+          <p:style>
+            <a:lnRef idx="2">
+              <a:schemeClr val="accent1">
+                <a:shade val="15000"/>
+              </a:schemeClr>
+            </a:lnRef>
+            <a:fillRef idx="1">
+              <a:schemeClr val="accent1"/>
+            </a:fillRef>
+            <a:effectRef idx="0">
+              <a:schemeClr val="accent1"/>
+            </a:effectRef>
+            <a:fontRef idx="minor">
+              <a:schemeClr val="lt1"/>
+            </a:fontRef>
+          </p:style>
+          <p:txBody>
+            <a:bodyPr rtlCol="0" anchor="ctr"/>
+            <a:lstStyle/>
+            <a:p>
+              <a:pPr algn="ctr"/>
+              <a:endParaRPr lang="en-US"/>
+            </a:p>
+          </p:txBody>
+        </p:sp>
+        <p:pic>
+          <p:nvPicPr>
+            <p:cNvPr id="26" name="Picture 25">
+              <a:extLst>
+                <a:ext uri="{FF2B5EF4-FFF2-40B4-BE49-F238E27FC236}">
+                  <a16:creationId xmlns:a16="http://schemas.microsoft.com/office/drawing/2014/main" id="{18C01312-3D3D-4C08-0990-34124515CDDD}"/>
+                </a:ext>
+              </a:extLst>
+            </p:cNvPr>
+            <p:cNvPicPr>
+              <a:picLocks noChangeAspect="1"/>
+            </p:cNvPicPr>
+            <p:nvPr/>
+          </p:nvPicPr>
+          <p:blipFill>
+            <a:blip r:embed="rId7">
+              <a:extLst>
+                <a:ext uri="{BEBA8EAE-BF5A-486C-A8C5-ECC9F3942E4B}">
+                  <a14:imgProps xmlns:a14="http://schemas.microsoft.com/office/drawing/2010/main">
+                    <a14:imgLayer r:embed="rId8">
+                      <a14:imgEffect>
+                        <a14:saturation sat="0"/>
+                      </a14:imgEffect>
+                    </a14:imgLayer>
+                  </a14:imgProps>
+                </a:ext>
+              </a:extLst>
+            </a:blip>
+            <a:stretch>
+              <a:fillRect/>
+            </a:stretch>
+          </p:blipFill>
+          <p:spPr>
+            <a:xfrm>
+              <a:off x="3933847" y="1818968"/>
+              <a:ext cx="457200" cy="457200"/>
+            </a:xfrm>
+            <a:prstGeom prst="rect">
+              <a:avLst/>
+            </a:prstGeom>
+          </p:spPr>
+        </p:pic>
+      </p:grpSp>
+      <p:pic>
+        <p:nvPicPr>
+          <p:cNvPr id="27" name="Picture 26">
+            <a:extLst>
+              <a:ext uri="{FF2B5EF4-FFF2-40B4-BE49-F238E27FC236}">
+                <a16:creationId xmlns:a16="http://schemas.microsoft.com/office/drawing/2014/main" id="{D5BB4EE8-C0DE-05CC-00B4-FB29A9005E81}"/>
+              </a:ext>
+            </a:extLst>
+          </p:cNvPr>
+          <p:cNvPicPr>
+            <a:picLocks noChangeAspect="1"/>
+          </p:cNvPicPr>
+          <p:nvPr/>
+        </p:nvPicPr>
+        <p:blipFill>
+          <a:blip r:embed="rId6"/>
+          <a:stretch>
+            <a:fillRect/>
+          </a:stretch>
+        </p:blipFill>
+        <p:spPr>
+          <a:xfrm>
+            <a:off x="6917573" y="1818968"/>
+            <a:ext cx="457200" cy="457200"/>
+          </a:xfrm>
+          <a:prstGeom prst="rect">
+            <a:avLst/>
+          </a:prstGeom>
+        </p:spPr>
+      </p:pic>
+      <p:pic>
+        <p:nvPicPr>
+          <p:cNvPr id="28" name="Picture 27">
+            <a:extLst>
+              <a:ext uri="{FF2B5EF4-FFF2-40B4-BE49-F238E27FC236}">
+                <a16:creationId xmlns:a16="http://schemas.microsoft.com/office/drawing/2014/main" id="{A64727C8-033C-C9A5-327D-0F1821F69CBF}"/>
+              </a:ext>
+            </a:extLst>
+          </p:cNvPr>
+          <p:cNvPicPr>
+            <a:picLocks noChangeAspect="1"/>
+          </p:cNvPicPr>
+          <p:nvPr/>
+        </p:nvPicPr>
+        <p:blipFill>
+          <a:blip r:embed="rId7">
+            <a:extLst>
+              <a:ext uri="{BEBA8EAE-BF5A-486C-A8C5-ECC9F3942E4B}">
+                <a14:imgProps xmlns:a14="http://schemas.microsoft.com/office/drawing/2010/main">
+                  <a14:imgLayer r:embed="rId8">
+                    <a14:imgEffect>
+                      <a14:saturation sat="0"/>
+                    </a14:imgEffect>
+                  </a14:imgLayer>
+                </a14:imgProps>
               </a:ext>
             </a:extLst>
           </a:blip>
@@ -7056,8 +7754,8 @@
         </p:blipFill>
         <p:spPr>
           <a:xfrm>
-            <a:off x="1103138" y="1388243"/>
-            <a:ext cx="3017526" cy="3950216"/>
+            <a:off x="9720879" y="1818968"/>
+            <a:ext cx="457200" cy="457200"/>
           </a:xfrm>
           <a:prstGeom prst="rect">
             <a:avLst/>
@@ -7066,10 +7764,10 @@
       </p:pic>
       <p:sp>
         <p:nvSpPr>
-          <p:cNvPr id="6" name="TextBox 5">
-            <a:extLst>
-              <a:ext uri="{FF2B5EF4-FFF2-40B4-BE49-F238E27FC236}">
-                <a16:creationId xmlns:a16="http://schemas.microsoft.com/office/drawing/2014/main" id="{A4057A34-A99D-48F4-A087-77D40043C767}"/>
+          <p:cNvPr id="42" name="TextBox 41">
+            <a:extLst>
+              <a:ext uri="{FF2B5EF4-FFF2-40B4-BE49-F238E27FC236}">
+                <a16:creationId xmlns:a16="http://schemas.microsoft.com/office/drawing/2014/main" id="{134603E0-C242-247C-289D-44241A3BFF96}"/>
               </a:ext>
             </a:extLst>
           </p:cNvPr>
@@ -7078,45 +7776,8 @@
         </p:nvSpPr>
         <p:spPr>
           <a:xfrm>
-            <a:off x="2914520" y="3767827"/>
-            <a:ext cx="924127" cy="230832"/>
-          </a:xfrm>
-          <a:prstGeom prst="rect">
-            <a:avLst/>
-          </a:prstGeom>
-          <a:solidFill>
-            <a:schemeClr val="bg1"/>
-          </a:solidFill>
-        </p:spPr>
-        <p:txBody>
-          <a:bodyPr wrap="square" rtlCol="0">
-            <a:spAutoFit/>
-          </a:bodyPr>
-          <a:lstStyle/>
-          <a:p>
-            <a:r>
-              <a:rPr lang="en-US" sz="900" b="1" dirty="0"/>
-              <a:t>539 features</a:t>
-            </a:r>
-          </a:p>
-        </p:txBody>
-      </p:sp>
-      <p:sp>
-        <p:nvSpPr>
-          <p:cNvPr id="7" name="TextBox 6">
-            <a:extLst>
-              <a:ext uri="{FF2B5EF4-FFF2-40B4-BE49-F238E27FC236}">
-                <a16:creationId xmlns:a16="http://schemas.microsoft.com/office/drawing/2014/main" id="{23A250BE-0B65-BE91-4449-C546ED0FCCDD}"/>
-              </a:ext>
-            </a:extLst>
-          </p:cNvPr>
-          <p:cNvSpPr txBox="1"/>
-          <p:nvPr/>
-        </p:nvSpPr>
-        <p:spPr>
-          <a:xfrm>
-            <a:off x="3012993" y="2428028"/>
-            <a:ext cx="886407" cy="230832"/>
+            <a:off x="1982583" y="4697198"/>
+            <a:ext cx="1418252" cy="369332"/>
           </a:xfrm>
           <a:prstGeom prst="rect">
             <a:avLst/>
@@ -7130,9 +7791,122 @@
           <a:lstStyle/>
           <a:p>
             <a:r>
-              <a:rPr lang="en-US" sz="900" b="1" dirty="0"/>
-              <a:t>224 features</a:t>
+              <a:rPr lang="en-US" sz="900" b="1" dirty="0">
+                <a:latin typeface="Arial" panose="020B0604020202020204" pitchFamily="34" charset="0"/>
+                <a:cs typeface="Arial" panose="020B0604020202020204" pitchFamily="34" charset="0"/>
+              </a:rPr>
+              <a:t>Point below cutoff</a:t>
             </a:r>
+          </a:p>
+          <a:p>
+            <a:r>
+              <a:rPr lang="en-US" sz="900" b="1" dirty="0">
+                <a:latin typeface="Arial" panose="020B0604020202020204" pitchFamily="34" charset="0"/>
+                <a:cs typeface="Arial" panose="020B0604020202020204" pitchFamily="34" charset="0"/>
+              </a:rPr>
+              <a:t>Point above cutoff</a:t>
+            </a:r>
+          </a:p>
+        </p:txBody>
+      </p:sp>
+      <p:sp>
+        <p:nvSpPr>
+          <p:cNvPr id="43" name="Oval 42">
+            <a:extLst>
+              <a:ext uri="{FF2B5EF4-FFF2-40B4-BE49-F238E27FC236}">
+                <a16:creationId xmlns:a16="http://schemas.microsoft.com/office/drawing/2014/main" id="{57BDB107-4E21-1368-C04F-54F46D86E8AF}"/>
+              </a:ext>
+            </a:extLst>
+          </p:cNvPr>
+          <p:cNvSpPr/>
+          <p:nvPr/>
+        </p:nvSpPr>
+        <p:spPr>
+          <a:xfrm>
+            <a:off x="1916899" y="4773881"/>
+            <a:ext cx="95250" cy="91440"/>
+          </a:xfrm>
+          <a:prstGeom prst="ellipse">
+            <a:avLst/>
+          </a:prstGeom>
+          <a:noFill/>
+        </p:spPr>
+        <p:style>
+          <a:lnRef idx="2">
+            <a:schemeClr val="accent1">
+              <a:shade val="15000"/>
+            </a:schemeClr>
+          </a:lnRef>
+          <a:fillRef idx="1">
+            <a:schemeClr val="accent1"/>
+          </a:fillRef>
+          <a:effectRef idx="0">
+            <a:schemeClr val="accent1"/>
+          </a:effectRef>
+          <a:fontRef idx="minor">
+            <a:schemeClr val="lt1"/>
+          </a:fontRef>
+        </p:style>
+        <p:txBody>
+          <a:bodyPr rtlCol="0" anchor="ctr"/>
+          <a:lstStyle/>
+          <a:p>
+            <a:pPr algn="ctr"/>
+            <a:endParaRPr lang="en-US"/>
+          </a:p>
+        </p:txBody>
+      </p:sp>
+      <p:sp>
+        <p:nvSpPr>
+          <p:cNvPr id="44" name="Oval 43">
+            <a:extLst>
+              <a:ext uri="{FF2B5EF4-FFF2-40B4-BE49-F238E27FC236}">
+                <a16:creationId xmlns:a16="http://schemas.microsoft.com/office/drawing/2014/main" id="{40ED73C7-B6EF-F67F-2360-01A04A3F3445}"/>
+              </a:ext>
+            </a:extLst>
+          </p:cNvPr>
+          <p:cNvSpPr/>
+          <p:nvPr/>
+        </p:nvSpPr>
+        <p:spPr>
+          <a:xfrm>
+            <a:off x="1916899" y="4905393"/>
+            <a:ext cx="95250" cy="91440"/>
+          </a:xfrm>
+          <a:prstGeom prst="ellipse">
+            <a:avLst/>
+          </a:prstGeom>
+          <a:solidFill>
+            <a:schemeClr val="tx1"/>
+          </a:solidFill>
+          <a:ln>
+            <a:solidFill>
+              <a:schemeClr val="tx1"/>
+            </a:solidFill>
+          </a:ln>
+        </p:spPr>
+        <p:style>
+          <a:lnRef idx="2">
+            <a:schemeClr val="accent1">
+              <a:shade val="15000"/>
+            </a:schemeClr>
+          </a:lnRef>
+          <a:fillRef idx="1">
+            <a:schemeClr val="accent1"/>
+          </a:fillRef>
+          <a:effectRef idx="0">
+            <a:schemeClr val="accent1"/>
+          </a:effectRef>
+          <a:fontRef idx="minor">
+            <a:schemeClr val="lt1"/>
+          </a:fontRef>
+        </p:style>
+        <p:txBody>
+          <a:bodyPr rtlCol="0" anchor="ctr"/>
+          <a:lstStyle/>
+          <a:p>
+            <a:pPr algn="ctr"/>
+            <a:endParaRPr lang="en-US"/>
           </a:p>
         </p:txBody>
       </p:sp>
@@ -7140,6 +7914,86 @@
     <p:extLst>
       <p:ext uri="{BB962C8B-B14F-4D97-AF65-F5344CB8AC3E}">
         <p14:creationId xmlns:p14="http://schemas.microsoft.com/office/powerpoint/2010/main" val="674222147"/>
+      </p:ext>
+    </p:extLst>
+  </p:cSld>
+  <p:clrMapOvr>
+    <a:masterClrMapping/>
+  </p:clrMapOvr>
+</p:sld>
+</file>
+
+<file path=ppt/slides/slide6.xml><?xml version="1.0" encoding="utf-8"?>
+<p:sld xmlns:a="http://schemas.openxmlformats.org/drawingml/2006/main" xmlns:r="http://schemas.openxmlformats.org/officeDocument/2006/relationships" xmlns:p="http://schemas.openxmlformats.org/presentationml/2006/main">
+  <p:cSld>
+    <p:spTree>
+      <p:nvGrpSpPr>
+        <p:cNvPr id="1" name=""/>
+        <p:cNvGrpSpPr/>
+        <p:nvPr/>
+      </p:nvGrpSpPr>
+      <p:grpSpPr>
+        <a:xfrm>
+          <a:off x="0" y="0"/>
+          <a:ext cx="0" cy="0"/>
+          <a:chOff x="0" y="0"/>
+          <a:chExt cx="0" cy="0"/>
+        </a:xfrm>
+      </p:grpSpPr>
+      <p:sp>
+        <p:nvSpPr>
+          <p:cNvPr id="2" name="Title 1">
+            <a:extLst>
+              <a:ext uri="{FF2B5EF4-FFF2-40B4-BE49-F238E27FC236}">
+                <a16:creationId xmlns:a16="http://schemas.microsoft.com/office/drawing/2014/main" id="{AAC2564F-7BEE-27B2-A2EA-FF450639F370}"/>
+              </a:ext>
+            </a:extLst>
+          </p:cNvPr>
+          <p:cNvSpPr>
+            <a:spLocks noGrp="1"/>
+          </p:cNvSpPr>
+          <p:nvPr>
+            <p:ph type="title"/>
+          </p:nvPr>
+        </p:nvSpPr>
+        <p:spPr/>
+        <p:txBody>
+          <a:bodyPr/>
+          <a:lstStyle/>
+          <a:p>
+            <a:endParaRPr lang="en-US"/>
+          </a:p>
+        </p:txBody>
+      </p:sp>
+      <p:sp>
+        <p:nvSpPr>
+          <p:cNvPr id="3" name="Content Placeholder 2">
+            <a:extLst>
+              <a:ext uri="{FF2B5EF4-FFF2-40B4-BE49-F238E27FC236}">
+                <a16:creationId xmlns:a16="http://schemas.microsoft.com/office/drawing/2014/main" id="{1EECE427-7061-DDBB-57F6-7FDF33541D02}"/>
+              </a:ext>
+            </a:extLst>
+          </p:cNvPr>
+          <p:cNvSpPr>
+            <a:spLocks noGrp="1"/>
+          </p:cNvSpPr>
+          <p:nvPr>
+            <p:ph idx="1"/>
+          </p:nvPr>
+        </p:nvSpPr>
+        <p:spPr/>
+        <p:txBody>
+          <a:bodyPr/>
+          <a:lstStyle/>
+          <a:p>
+            <a:endParaRPr lang="en-US"/>
+          </a:p>
+        </p:txBody>
+      </p:sp>
+    </p:spTree>
+    <p:extLst>
+      <p:ext uri="{BB962C8B-B14F-4D97-AF65-F5344CB8AC3E}">
+        <p14:creationId xmlns:p14="http://schemas.microsoft.com/office/powerpoint/2010/main" val="2128333181"/>
       </p:ext>
     </p:extLst>
   </p:cSld>

</xml_diff>

<commit_message>
Added back in the isotopic packet filter
</commit_message>
<xml_diff>
--- a/figures/figures for patent application.pptx
+++ b/figures/figures for patent application.pptx
@@ -7942,54 +7942,239 @@
       </p:grpSpPr>
       <p:sp>
         <p:nvSpPr>
-          <p:cNvPr id="2" name="Title 1">
-            <a:extLst>
-              <a:ext uri="{FF2B5EF4-FFF2-40B4-BE49-F238E27FC236}">
-                <a16:creationId xmlns:a16="http://schemas.microsoft.com/office/drawing/2014/main" id="{AAC2564F-7BEE-27B2-A2EA-FF450639F370}"/>
+          <p:cNvPr id="4" name="AutoShape 2">
+            <a:extLst>
+              <a:ext uri="{FF2B5EF4-FFF2-40B4-BE49-F238E27FC236}">
+                <a16:creationId xmlns:a16="http://schemas.microsoft.com/office/drawing/2014/main" id="{E252AF72-D401-0CBB-1724-6C83A06D3DA2}"/>
               </a:ext>
             </a:extLst>
           </p:cNvPr>
           <p:cNvSpPr>
-            <a:spLocks noGrp="1"/>
+            <a:spLocks noChangeAspect="1" noChangeArrowheads="1"/>
           </p:cNvSpPr>
-          <p:nvPr>
-            <p:ph type="title"/>
-          </p:nvPr>
+          <p:nvPr/>
         </p:nvSpPr>
-        <p:spPr/>
+        <p:spPr bwMode="auto">
+          <a:xfrm>
+            <a:off x="5943600" y="3276600"/>
+            <a:ext cx="304800" cy="304800"/>
+          </a:xfrm>
+          <a:prstGeom prst="rect">
+            <a:avLst/>
+          </a:prstGeom>
+          <a:noFill/>
+          <a:extLst>
+            <a:ext uri="{909E8E84-426E-40DD-AFC4-6F175D3DCCD1}">
+              <a14:hiddenFill xmlns:a14="http://schemas.microsoft.com/office/drawing/2010/main">
+                <a:solidFill>
+                  <a:srgbClr val="FFFFFF"/>
+                </a:solidFill>
+              </a14:hiddenFill>
+            </a:ext>
+          </a:extLst>
+        </p:spPr>
         <p:txBody>
-          <a:bodyPr/>
+          <a:bodyPr vert="horz" wrap="square" lIns="91440" tIns="45720" rIns="91440" bIns="45720" numCol="1" anchor="t" anchorCtr="0" compatLnSpc="1">
+            <a:prstTxWarp prst="textNoShape">
+              <a:avLst/>
+            </a:prstTxWarp>
+          </a:bodyPr>
           <a:lstStyle/>
           <a:p>
             <a:endParaRPr lang="en-US"/>
           </a:p>
         </p:txBody>
       </p:sp>
+      <p:pic>
+        <p:nvPicPr>
+          <p:cNvPr id="6" name="Picture 5" descr="A graph of a number of objects&#10;&#10;AI-generated content may be incorrect.">
+            <a:extLst>
+              <a:ext uri="{FF2B5EF4-FFF2-40B4-BE49-F238E27FC236}">
+                <a16:creationId xmlns:a16="http://schemas.microsoft.com/office/drawing/2014/main" id="{992CD6EE-EE8F-E3E4-6D2E-1886FE020CBD}"/>
+              </a:ext>
+            </a:extLst>
+          </p:cNvPr>
+          <p:cNvPicPr>
+            <a:picLocks noChangeAspect="1"/>
+          </p:cNvPicPr>
+          <p:nvPr/>
+        </p:nvPicPr>
+        <p:blipFill>
+          <a:blip r:embed="rId2">
+            <a:extLst>
+              <a:ext uri="{28A0092B-C50C-407E-A947-70E740481C1C}">
+                <a14:useLocalDpi xmlns:a14="http://schemas.microsoft.com/office/drawing/2010/main" val="0"/>
+              </a:ext>
+            </a:extLst>
+          </a:blip>
+          <a:stretch>
+            <a:fillRect/>
+          </a:stretch>
+        </p:blipFill>
+        <p:spPr>
+          <a:xfrm>
+            <a:off x="3645408" y="0"/>
+            <a:ext cx="4901184" cy="6858000"/>
+          </a:xfrm>
+          <a:prstGeom prst="rect">
+            <a:avLst/>
+          </a:prstGeom>
+        </p:spPr>
+      </p:pic>
       <p:sp>
         <p:nvSpPr>
-          <p:cNvPr id="3" name="Content Placeholder 2">
-            <a:extLst>
-              <a:ext uri="{FF2B5EF4-FFF2-40B4-BE49-F238E27FC236}">
-                <a16:creationId xmlns:a16="http://schemas.microsoft.com/office/drawing/2014/main" id="{1EECE427-7061-DDBB-57F6-7FDF33541D02}"/>
-              </a:ext>
-            </a:extLst>
-          </p:cNvPr>
-          <p:cNvSpPr>
-            <a:spLocks noGrp="1"/>
-          </p:cNvSpPr>
-          <p:nvPr>
-            <p:ph idx="1"/>
-          </p:nvPr>
+          <p:cNvPr id="7" name="Freeform: Shape 6">
+            <a:extLst>
+              <a:ext uri="{FF2B5EF4-FFF2-40B4-BE49-F238E27FC236}">
+                <a16:creationId xmlns:a16="http://schemas.microsoft.com/office/drawing/2014/main" id="{D7D8AE5D-B1DB-F18D-8CAF-5F7E8294DA86}"/>
+              </a:ext>
+            </a:extLst>
+          </p:cNvPr>
+          <p:cNvSpPr/>
+          <p:nvPr/>
         </p:nvSpPr>
-        <p:spPr/>
+        <p:spPr>
+          <a:xfrm>
+            <a:off x="8039100" y="3662363"/>
+            <a:ext cx="614363" cy="2381250"/>
+          </a:xfrm>
+          <a:custGeom>
+            <a:avLst/>
+            <a:gdLst>
+              <a:gd name="connsiteX0" fmla="*/ 47625 w 614363"/>
+              <a:gd name="connsiteY0" fmla="*/ 219075 h 2381250"/>
+              <a:gd name="connsiteX1" fmla="*/ 0 w 614363"/>
+              <a:gd name="connsiteY1" fmla="*/ 2266950 h 2381250"/>
+              <a:gd name="connsiteX2" fmla="*/ 138113 w 614363"/>
+              <a:gd name="connsiteY2" fmla="*/ 2381250 h 2381250"/>
+              <a:gd name="connsiteX3" fmla="*/ 376238 w 614363"/>
+              <a:gd name="connsiteY3" fmla="*/ 2362200 h 2381250"/>
+              <a:gd name="connsiteX4" fmla="*/ 614363 w 614363"/>
+              <a:gd name="connsiteY4" fmla="*/ 285750 h 2381250"/>
+              <a:gd name="connsiteX5" fmla="*/ 523875 w 614363"/>
+              <a:gd name="connsiteY5" fmla="*/ 0 h 2381250"/>
+              <a:gd name="connsiteX6" fmla="*/ 47625 w 614363"/>
+              <a:gd name="connsiteY6" fmla="*/ 219075 h 2381250"/>
+            </a:gdLst>
+            <a:ahLst/>
+            <a:cxnLst>
+              <a:cxn ang="0">
+                <a:pos x="connsiteX0" y="connsiteY0"/>
+              </a:cxn>
+              <a:cxn ang="0">
+                <a:pos x="connsiteX1" y="connsiteY1"/>
+              </a:cxn>
+              <a:cxn ang="0">
+                <a:pos x="connsiteX2" y="connsiteY2"/>
+              </a:cxn>
+              <a:cxn ang="0">
+                <a:pos x="connsiteX3" y="connsiteY3"/>
+              </a:cxn>
+              <a:cxn ang="0">
+                <a:pos x="connsiteX4" y="connsiteY4"/>
+              </a:cxn>
+              <a:cxn ang="0">
+                <a:pos x="connsiteX5" y="connsiteY5"/>
+              </a:cxn>
+              <a:cxn ang="0">
+                <a:pos x="connsiteX6" y="connsiteY6"/>
+              </a:cxn>
+            </a:cxnLst>
+            <a:rect l="l" t="t" r="r" b="b"/>
+            <a:pathLst>
+              <a:path w="614363" h="2381250">
+                <a:moveTo>
+                  <a:pt x="47625" y="219075"/>
+                </a:moveTo>
+                <a:lnTo>
+                  <a:pt x="0" y="2266950"/>
+                </a:lnTo>
+                <a:lnTo>
+                  <a:pt x="138113" y="2381250"/>
+                </a:lnTo>
+                <a:lnTo>
+                  <a:pt x="376238" y="2362200"/>
+                </a:lnTo>
+                <a:lnTo>
+                  <a:pt x="614363" y="285750"/>
+                </a:lnTo>
+                <a:lnTo>
+                  <a:pt x="523875" y="0"/>
+                </a:lnTo>
+                <a:lnTo>
+                  <a:pt x="47625" y="219075"/>
+                </a:lnTo>
+                <a:close/>
+              </a:path>
+            </a:pathLst>
+          </a:custGeom>
+          <a:solidFill>
+            <a:schemeClr val="bg1"/>
+          </a:solidFill>
+          <a:ln>
+            <a:noFill/>
+          </a:ln>
+        </p:spPr>
+        <p:style>
+          <a:lnRef idx="2">
+            <a:schemeClr val="accent1">
+              <a:shade val="15000"/>
+            </a:schemeClr>
+          </a:lnRef>
+          <a:fillRef idx="1">
+            <a:schemeClr val="accent1"/>
+          </a:fillRef>
+          <a:effectRef idx="0">
+            <a:schemeClr val="accent1"/>
+          </a:effectRef>
+          <a:fontRef idx="minor">
+            <a:schemeClr val="lt1"/>
+          </a:fontRef>
+        </p:style>
         <p:txBody>
-          <a:bodyPr/>
+          <a:bodyPr rtlCol="0" anchor="ctr"/>
           <a:lstStyle/>
           <a:p>
+            <a:pPr algn="ctr"/>
             <a:endParaRPr lang="en-US"/>
           </a:p>
         </p:txBody>
       </p:sp>
+      <p:pic>
+        <p:nvPicPr>
+          <p:cNvPr id="8" name="Picture 7" descr="A graph of a number of objects&#10;&#10;AI-generated content may be incorrect.">
+            <a:extLst>
+              <a:ext uri="{FF2B5EF4-FFF2-40B4-BE49-F238E27FC236}">
+                <a16:creationId xmlns:a16="http://schemas.microsoft.com/office/drawing/2014/main" id="{70246893-127F-367E-54D1-F51CEA51197A}"/>
+              </a:ext>
+            </a:extLst>
+          </p:cNvPr>
+          <p:cNvPicPr>
+            <a:picLocks noChangeAspect="1"/>
+          </p:cNvPicPr>
+          <p:nvPr/>
+        </p:nvPicPr>
+        <p:blipFill>
+          <a:blip r:embed="rId2">
+            <a:extLst>
+              <a:ext uri="{28A0092B-C50C-407E-A947-70E740481C1C}">
+                <a14:useLocalDpi xmlns:a14="http://schemas.microsoft.com/office/drawing/2010/main" val="0"/>
+              </a:ext>
+            </a:extLst>
+          </a:blip>
+          <a:srcRect l="88479" b="62916"/>
+          <a:stretch/>
+        </p:blipFill>
+        <p:spPr>
+          <a:xfrm>
+            <a:off x="7987756" y="3652840"/>
+            <a:ext cx="564642" cy="2543175"/>
+          </a:xfrm>
+          <a:prstGeom prst="rect">
+            <a:avLst/>
+          </a:prstGeom>
+        </p:spPr>
+      </p:pic>
     </p:spTree>
     <p:extLst>
       <p:ext uri="{BB962C8B-B14F-4D97-AF65-F5344CB8AC3E}">

</xml_diff>